<commit_message>
docs(marketing): drop the Colorado anchor card from the deck's ask slide
Slide 7 held a two-card layout whose right half was a placeholder for a named
Colorado agency, workflow owner, and workflow. There is no such conversation
yet, and a showcase application is the wrong place to imply one, so the card is
gone rather than filled: the slide is now a single pilot-request card stating
the ask as three constraints — scope, people, result — over the same status
line. Nothing reads as missing, and the deck no longer ships text addressed to
its own author.

Adds the CHANGELOG entry for the deck, and corrects the README's slide map and
pre-submission note to match.

Co-Authored-By: Claude Opus 5 <noreply@anthropic.com>
Claude-Session: https://claude.ai/code/session_014wx66ZsorFsmFrkYkfMbu3
</commit_message>
<xml_diff>
--- a/marketing/decks/AI-Identity-DenAI-Showcase-2026-v4.pptx
+++ b/marketing/decks/AI-Identity-DenAI-Showcase-2026-v4.pptx
@@ -1037,7 +1037,7 @@
           <a:p>
             <a:r>
               <a:rPr lang="en-US" dirty="0"/>
-              <a:t>4:15–4:40 — ACTION REQUIRED: replace the amber card before you submit or present. A named Colorado workflow is the single highest-value edit in this deck. Also decide in advance how you answer 'are you raising?' — the deck deliberately does not claim either way.</a:t>
+              <a:t>4:15–4:40 — The ask, said once and plainly; do not soften it into 'we would love to explore.' Name the three constraints and stop. If someone asks whether a city is already using this, answer straight — the deck claims nothing either way. Decide in advance how you answer 'are you raising?'</a:t>
             </a:r>
             <a:endParaRPr lang="en-US" dirty="0"/>
           </a:p>
@@ -7874,11 +7874,11 @@
         <p:spPr>
           <a:xfrm>
             <a:off x="685800" y="1700784"/>
-            <a:ext cx="5577840" cy="3127248"/>
+            <a:ext cx="10820095" cy="3054096"/>
           </a:xfrm>
           <a:prstGeom prst="roundRect">
             <a:avLst>
-              <a:gd name="adj" fmla="val 1462"/>
+              <a:gd name="adj" fmla="val 1497"/>
             </a:avLst>
           </a:prstGeom>
           <a:solidFill>
@@ -7947,23 +7947,23 @@
         <p:spPr>
           <a:xfrm>
             <a:off x="1069848" y="2304288"/>
-            <a:ext cx="4809744" cy="402336"/>
-          </a:xfrm>
-          <a:prstGeom prst="rect">
-            <a:avLst/>
-          </a:prstGeom>
-          <a:noFill/>
-          <a:ln/>
-        </p:spPr>
-        <p:txBody>
-          <a:bodyPr wrap="square" lIns="0" tIns="0" rIns="0" bIns="0" rtlCol="0" anchor="ctr"/>
-          <a:lstStyle/>
-          <a:p>
-            <a:pPr indent="0" marL="0">
-              <a:buNone/>
-            </a:pPr>
-            <a:r>
-              <a:rPr lang="en-US" sz="2300" b="1" dirty="0">
+            <a:ext cx="7315200" cy="420624"/>
+          </a:xfrm>
+          <a:prstGeom prst="rect">
+            <a:avLst/>
+          </a:prstGeom>
+          <a:noFill/>
+          <a:ln/>
+        </p:spPr>
+        <p:txBody>
+          <a:bodyPr wrap="square" lIns="0" tIns="0" rIns="0" bIns="0" rtlCol="0" anchor="ctr"/>
+          <a:lstStyle/>
+          <a:p>
+            <a:pPr indent="0" marL="0">
+              <a:buNone/>
+            </a:pPr>
+            <a:r>
+              <a:rPr lang="en-US" sz="2500" b="1" dirty="0">
                 <a:solidFill>
                   <a:srgbClr val="1E2761"/>
                 </a:solidFill>
@@ -7973,44 +7973,152 @@
               </a:rPr>
               <a:t>One city workflow, end to end</a:t>
             </a:r>
-            <a:endParaRPr lang="en-US" sz="2300" dirty="0"/>
-          </a:p>
-        </p:txBody>
-      </p:sp>
-      <p:sp>
-        <p:nvSpPr>
-          <p:cNvPr id="7" name="Text 5"/>
-          <p:cNvSpPr txBox="1"/>
-          <p:nvPr/>
-        </p:nvSpPr>
-        <p:spPr>
-          <a:xfrm>
-            <a:off x="1069848" y="2889504"/>
-            <a:ext cx="914400" cy="274320"/>
-          </a:xfrm>
-          <a:prstGeom prst="rect">
-            <a:avLst/>
-          </a:prstGeom>
-          <a:noFill/>
-          <a:ln/>
-        </p:spPr>
-        <p:txBody>
-          <a:bodyPr wrap="square" lIns="0" tIns="0" rIns="0" bIns="0" rtlCol="0" anchor="ctr"/>
-          <a:lstStyle/>
-          <a:p>
-            <a:pPr indent="0" marL="0">
-              <a:buNone/>
-            </a:pPr>
-            <a:r>
-              <a:rPr lang="en-US" sz="1300" b="1" dirty="0">
+            <a:endParaRPr lang="en-US" sz="2500" dirty="0"/>
+          </a:p>
+        </p:txBody>
+      </p:sp>
+      <p:sp>
+        <p:nvSpPr>
+          <p:cNvPr id="7" name="Shape 5"/>
+          <p:cNvSpPr/>
+          <p:nvPr/>
+        </p:nvSpPr>
+        <p:spPr>
+          <a:xfrm>
+            <a:off x="1069848" y="2980944"/>
+            <a:ext cx="384048" cy="384048"/>
+          </a:xfrm>
+          <a:prstGeom prst="roundRect">
+            <a:avLst>
+              <a:gd name="adj" fmla="val 19048"/>
+            </a:avLst>
+          </a:prstGeom>
+          <a:solidFill>
+            <a:srgbClr val="1E2761"/>
+          </a:solidFill>
+          <a:ln w="12700">
+            <a:solidFill>
+              <a:srgbClr val="1E2761"/>
+            </a:solidFill>
+            <a:prstDash val="solid"/>
+          </a:ln>
+        </p:spPr>
+      </p:sp>
+      <p:sp>
+        <p:nvSpPr>
+          <p:cNvPr id="8" name="Text 6"/>
+          <p:cNvSpPr txBox="1"/>
+          <p:nvPr/>
+        </p:nvSpPr>
+        <p:spPr>
+          <a:xfrm>
+            <a:off x="1069848" y="2980944"/>
+            <a:ext cx="384048" cy="384048"/>
+          </a:xfrm>
+          <a:prstGeom prst="rect">
+            <a:avLst/>
+          </a:prstGeom>
+          <a:noFill/>
+          <a:ln/>
+        </p:spPr>
+        <p:txBody>
+          <a:bodyPr wrap="square" lIns="0" tIns="0" rIns="0" bIns="0" rtlCol="0" anchor="ctr"/>
+          <a:lstStyle/>
+          <a:p>
+            <a:pPr algn="ctr" indent="0" marL="0">
+              <a:buNone/>
+            </a:pPr>
+            <a:r>
+              <a:rPr lang="en-US" sz="1100" b="1" dirty="0">
+                <a:solidFill>
+                  <a:srgbClr val="FFFFFF"/>
+                </a:solidFill>
+                <a:latin typeface="Courier New" pitchFamily="34" charset="0"/>
+                <a:ea typeface="Courier New" pitchFamily="34" charset="-122"/>
+                <a:cs typeface="Courier New" pitchFamily="34" charset="-120"/>
+              </a:rPr>
+              <a:t>01</a:t>
+            </a:r>
+            <a:endParaRPr lang="en-US" sz="1100" dirty="0"/>
+          </a:p>
+        </p:txBody>
+      </p:sp>
+      <p:sp>
+        <p:nvSpPr>
+          <p:cNvPr id="9" name="Text 7"/>
+          <p:cNvSpPr txBox="1"/>
+          <p:nvPr/>
+        </p:nvSpPr>
+        <p:spPr>
+          <a:xfrm>
+            <a:off x="1069848" y="3529584"/>
+            <a:ext cx="3044952" cy="329184"/>
+          </a:xfrm>
+          <a:prstGeom prst="rect">
+            <a:avLst/>
+          </a:prstGeom>
+          <a:noFill/>
+          <a:ln/>
+        </p:spPr>
+        <p:txBody>
+          <a:bodyPr wrap="square" lIns="0" tIns="0" rIns="0" bIns="0" rtlCol="0" anchor="ctr"/>
+          <a:lstStyle/>
+          <a:p>
+            <a:pPr indent="0" marL="0">
+              <a:buNone/>
+            </a:pPr>
+            <a:r>
+              <a:rPr lang="en-US" sz="1900" b="1" dirty="0">
                 <a:solidFill>
                   <a:srgbClr val="1E2761"/>
+                </a:solidFill>
+                <a:latin typeface="Cambria" pitchFamily="34" charset="0"/>
+                <a:ea typeface="Cambria" pitchFamily="34" charset="-122"/>
+                <a:cs typeface="Cambria" pitchFamily="34" charset="-120"/>
+              </a:rPr>
+              <a:t>Scope</a:t>
+            </a:r>
+            <a:endParaRPr lang="en-US" sz="1900" dirty="0"/>
+          </a:p>
+        </p:txBody>
+      </p:sp>
+      <p:sp>
+        <p:nvSpPr>
+          <p:cNvPr id="10" name="Text 8"/>
+          <p:cNvSpPr txBox="1"/>
+          <p:nvPr/>
+        </p:nvSpPr>
+        <p:spPr>
+          <a:xfrm>
+            <a:off x="1069848" y="3950208"/>
+            <a:ext cx="3044952" cy="658368"/>
+          </a:xfrm>
+          <a:prstGeom prst="rect">
+            <a:avLst/>
+          </a:prstGeom>
+          <a:noFill/>
+          <a:ln/>
+        </p:spPr>
+        <p:txBody>
+          <a:bodyPr wrap="square" lIns="0" tIns="0" rIns="0" bIns="0" rtlCol="0" anchor="ctr"/>
+          <a:lstStyle/>
+          <a:p>
+            <a:pPr indent="0" marL="0">
+              <a:lnSpc>
+                <a:spcPts val="1900"/>
+              </a:lnSpc>
+              <a:buNone/>
+            </a:pPr>
+            <a:r>
+              <a:rPr lang="en-US" sz="1300" dirty="0">
+                <a:solidFill>
+                  <a:srgbClr val="5B6883"/>
                 </a:solidFill>
                 <a:latin typeface="Calibri" pitchFamily="34" charset="0"/>
                 <a:ea typeface="Calibri" pitchFamily="34" charset="-122"/>
                 <a:cs typeface="Calibri" pitchFamily="34" charset="-120"/>
               </a:rPr>
-              <a:t>Scope</a:t>
+              <a:t>A single agent workflow with a real spending or data boundary.</a:t>
             </a:r>
             <a:endParaRPr lang="en-US" sz="1300" dirty="0"/>
           </a:p>
@@ -8018,14 +8126,119 @@
       </p:sp>
       <p:sp>
         <p:nvSpPr>
-          <p:cNvPr id="8" name="Text 6"/>
-          <p:cNvSpPr txBox="1"/>
-          <p:nvPr/>
-        </p:nvSpPr>
-        <p:spPr>
-          <a:xfrm>
-            <a:off x="2057400" y="2889504"/>
-            <a:ext cx="3840480" cy="512064"/>
+          <p:cNvPr id="11" name="Shape 9"/>
+          <p:cNvSpPr/>
+          <p:nvPr/>
+        </p:nvSpPr>
+        <p:spPr>
+          <a:xfrm>
+            <a:off x="4572000" y="2980944"/>
+            <a:ext cx="384048" cy="384048"/>
+          </a:xfrm>
+          <a:prstGeom prst="roundRect">
+            <a:avLst>
+              <a:gd name="adj" fmla="val 19048"/>
+            </a:avLst>
+          </a:prstGeom>
+          <a:solidFill>
+            <a:srgbClr val="1E2761"/>
+          </a:solidFill>
+          <a:ln w="12700">
+            <a:solidFill>
+              <a:srgbClr val="1E2761"/>
+            </a:solidFill>
+            <a:prstDash val="solid"/>
+          </a:ln>
+        </p:spPr>
+      </p:sp>
+      <p:sp>
+        <p:nvSpPr>
+          <p:cNvPr id="12" name="Text 10"/>
+          <p:cNvSpPr txBox="1"/>
+          <p:nvPr/>
+        </p:nvSpPr>
+        <p:spPr>
+          <a:xfrm>
+            <a:off x="4572000" y="2980944"/>
+            <a:ext cx="384048" cy="384048"/>
+          </a:xfrm>
+          <a:prstGeom prst="rect">
+            <a:avLst/>
+          </a:prstGeom>
+          <a:noFill/>
+          <a:ln/>
+        </p:spPr>
+        <p:txBody>
+          <a:bodyPr wrap="square" lIns="0" tIns="0" rIns="0" bIns="0" rtlCol="0" anchor="ctr"/>
+          <a:lstStyle/>
+          <a:p>
+            <a:pPr algn="ctr" indent="0" marL="0">
+              <a:buNone/>
+            </a:pPr>
+            <a:r>
+              <a:rPr lang="en-US" sz="1100" b="1" dirty="0">
+                <a:solidFill>
+                  <a:srgbClr val="FFFFFF"/>
+                </a:solidFill>
+                <a:latin typeface="Courier New" pitchFamily="34" charset="0"/>
+                <a:ea typeface="Courier New" pitchFamily="34" charset="-122"/>
+                <a:cs typeface="Courier New" pitchFamily="34" charset="-120"/>
+              </a:rPr>
+              <a:t>02</a:t>
+            </a:r>
+            <a:endParaRPr lang="en-US" sz="1100" dirty="0"/>
+          </a:p>
+        </p:txBody>
+      </p:sp>
+      <p:sp>
+        <p:nvSpPr>
+          <p:cNvPr id="13" name="Text 11"/>
+          <p:cNvSpPr txBox="1"/>
+          <p:nvPr/>
+        </p:nvSpPr>
+        <p:spPr>
+          <a:xfrm>
+            <a:off x="4572000" y="3529584"/>
+            <a:ext cx="3044952" cy="329184"/>
+          </a:xfrm>
+          <a:prstGeom prst="rect">
+            <a:avLst/>
+          </a:prstGeom>
+          <a:noFill/>
+          <a:ln/>
+        </p:spPr>
+        <p:txBody>
+          <a:bodyPr wrap="square" lIns="0" tIns="0" rIns="0" bIns="0" rtlCol="0" anchor="ctr"/>
+          <a:lstStyle/>
+          <a:p>
+            <a:pPr indent="0" marL="0">
+              <a:buNone/>
+            </a:pPr>
+            <a:r>
+              <a:rPr lang="en-US" sz="1900" b="1" dirty="0">
+                <a:solidFill>
+                  <a:srgbClr val="1E2761"/>
+                </a:solidFill>
+                <a:latin typeface="Cambria" pitchFamily="34" charset="0"/>
+                <a:ea typeface="Cambria" pitchFamily="34" charset="-122"/>
+                <a:cs typeface="Cambria" pitchFamily="34" charset="-120"/>
+              </a:rPr>
+              <a:t>People</a:t>
+            </a:r>
+            <a:endParaRPr lang="en-US" sz="1900" dirty="0"/>
+          </a:p>
+        </p:txBody>
+      </p:sp>
+      <p:sp>
+        <p:nvSpPr>
+          <p:cNvPr id="14" name="Text 12"/>
+          <p:cNvSpPr txBox="1"/>
+          <p:nvPr/>
+        </p:nvSpPr>
+        <p:spPr>
+          <a:xfrm>
+            <a:off x="4572000" y="3950208"/>
+            <a:ext cx="3044952" cy="658368"/>
           </a:xfrm>
           <a:prstGeom prst="rect">
             <a:avLst/>
@@ -8039,7 +8252,7 @@
           <a:p>
             <a:pPr indent="0" marL="0">
               <a:lnSpc>
-                <a:spcPts val="1800"/>
+                <a:spcPts val="1900"/>
               </a:lnSpc>
               <a:buNone/>
             </a:pPr>
@@ -8052,7 +8265,7 @@
                 <a:ea typeface="Calibri" pitchFamily="34" charset="-122"/>
                 <a:cs typeface="Calibri" pitchFamily="34" charset="-120"/>
               </a:rPr>
-              <a:t>A single agent workflow with a real spending or data boundary.</a:t>
+              <a:t>One technical owner on the city side. No procurement cycle to start.</a:t>
             </a:r>
             <a:endParaRPr lang="en-US" sz="1300" dirty="0"/>
           </a:p>
@@ -8060,38 +8273,146 @@
       </p:sp>
       <p:sp>
         <p:nvSpPr>
-          <p:cNvPr id="9" name="Text 7"/>
-          <p:cNvSpPr txBox="1"/>
-          <p:nvPr/>
-        </p:nvSpPr>
-        <p:spPr>
-          <a:xfrm>
-            <a:off x="1069848" y="3529584"/>
-            <a:ext cx="914400" cy="274320"/>
-          </a:xfrm>
-          <a:prstGeom prst="rect">
-            <a:avLst/>
-          </a:prstGeom>
-          <a:noFill/>
-          <a:ln/>
-        </p:spPr>
-        <p:txBody>
-          <a:bodyPr wrap="square" lIns="0" tIns="0" rIns="0" bIns="0" rtlCol="0" anchor="ctr"/>
-          <a:lstStyle/>
-          <a:p>
-            <a:pPr indent="0" marL="0">
-              <a:buNone/>
-            </a:pPr>
-            <a:r>
-              <a:rPr lang="en-US" sz="1300" b="1" dirty="0">
+          <p:cNvPr id="15" name="Shape 13"/>
+          <p:cNvSpPr/>
+          <p:nvPr/>
+        </p:nvSpPr>
+        <p:spPr>
+          <a:xfrm>
+            <a:off x="8074152" y="2980944"/>
+            <a:ext cx="384048" cy="384048"/>
+          </a:xfrm>
+          <a:prstGeom prst="roundRect">
+            <a:avLst>
+              <a:gd name="adj" fmla="val 19048"/>
+            </a:avLst>
+          </a:prstGeom>
+          <a:solidFill>
+            <a:srgbClr val="1E2761"/>
+          </a:solidFill>
+          <a:ln w="12700">
+            <a:solidFill>
+              <a:srgbClr val="1E2761"/>
+            </a:solidFill>
+            <a:prstDash val="solid"/>
+          </a:ln>
+        </p:spPr>
+      </p:sp>
+      <p:sp>
+        <p:nvSpPr>
+          <p:cNvPr id="16" name="Text 14"/>
+          <p:cNvSpPr txBox="1"/>
+          <p:nvPr/>
+        </p:nvSpPr>
+        <p:spPr>
+          <a:xfrm>
+            <a:off x="8074152" y="2980944"/>
+            <a:ext cx="384048" cy="384048"/>
+          </a:xfrm>
+          <a:prstGeom prst="rect">
+            <a:avLst/>
+          </a:prstGeom>
+          <a:noFill/>
+          <a:ln/>
+        </p:spPr>
+        <p:txBody>
+          <a:bodyPr wrap="square" lIns="0" tIns="0" rIns="0" bIns="0" rtlCol="0" anchor="ctr"/>
+          <a:lstStyle/>
+          <a:p>
+            <a:pPr algn="ctr" indent="0" marL="0">
+              <a:buNone/>
+            </a:pPr>
+            <a:r>
+              <a:rPr lang="en-US" sz="1100" b="1" dirty="0">
+                <a:solidFill>
+                  <a:srgbClr val="FFFFFF"/>
+                </a:solidFill>
+                <a:latin typeface="Courier New" pitchFamily="34" charset="0"/>
+                <a:ea typeface="Courier New" pitchFamily="34" charset="-122"/>
+                <a:cs typeface="Courier New" pitchFamily="34" charset="-120"/>
+              </a:rPr>
+              <a:t>03</a:t>
+            </a:r>
+            <a:endParaRPr lang="en-US" sz="1100" dirty="0"/>
+          </a:p>
+        </p:txBody>
+      </p:sp>
+      <p:sp>
+        <p:nvSpPr>
+          <p:cNvPr id="17" name="Text 15"/>
+          <p:cNvSpPr txBox="1"/>
+          <p:nvPr/>
+        </p:nvSpPr>
+        <p:spPr>
+          <a:xfrm>
+            <a:off x="8074152" y="3529584"/>
+            <a:ext cx="3044952" cy="329184"/>
+          </a:xfrm>
+          <a:prstGeom prst="rect">
+            <a:avLst/>
+          </a:prstGeom>
+          <a:noFill/>
+          <a:ln/>
+        </p:spPr>
+        <p:txBody>
+          <a:bodyPr wrap="square" lIns="0" tIns="0" rIns="0" bIns="0" rtlCol="0" anchor="ctr"/>
+          <a:lstStyle/>
+          <a:p>
+            <a:pPr indent="0" marL="0">
+              <a:buNone/>
+            </a:pPr>
+            <a:r>
+              <a:rPr lang="en-US" sz="1900" b="1" dirty="0">
                 <a:solidFill>
                   <a:srgbClr val="1E2761"/>
+                </a:solidFill>
+                <a:latin typeface="Cambria" pitchFamily="34" charset="0"/>
+                <a:ea typeface="Cambria" pitchFamily="34" charset="-122"/>
+                <a:cs typeface="Cambria" pitchFamily="34" charset="-120"/>
+              </a:rPr>
+              <a:t>Result</a:t>
+            </a:r>
+            <a:endParaRPr lang="en-US" sz="1900" dirty="0"/>
+          </a:p>
+        </p:txBody>
+      </p:sp>
+      <p:sp>
+        <p:nvSpPr>
+          <p:cNvPr id="18" name="Text 16"/>
+          <p:cNvSpPr txBox="1"/>
+          <p:nvPr/>
+        </p:nvSpPr>
+        <p:spPr>
+          <a:xfrm>
+            <a:off x="8074152" y="3950208"/>
+            <a:ext cx="3044952" cy="658368"/>
+          </a:xfrm>
+          <a:prstGeom prst="rect">
+            <a:avLst/>
+          </a:prstGeom>
+          <a:noFill/>
+          <a:ln/>
+        </p:spPr>
+        <p:txBody>
+          <a:bodyPr wrap="square" lIns="0" tIns="0" rIns="0" bIns="0" rtlCol="0" anchor="ctr"/>
+          <a:lstStyle/>
+          <a:p>
+            <a:pPr indent="0" marL="0">
+              <a:lnSpc>
+                <a:spcPts val="1900"/>
+              </a:lnSpc>
+              <a:buNone/>
+            </a:pPr>
+            <a:r>
+              <a:rPr lang="en-US" sz="1300" dirty="0">
+                <a:solidFill>
+                  <a:srgbClr val="5B6883"/>
                 </a:solidFill>
                 <a:latin typeface="Calibri" pitchFamily="34" charset="0"/>
                 <a:ea typeface="Calibri" pitchFamily="34" charset="-122"/>
                 <a:cs typeface="Calibri" pitchFamily="34" charset="-120"/>
               </a:rPr>
-              <a:t>People</a:t>
+              <a:t>Agent identity, enforced policy, and evidence a third party can verify.</a:t>
             </a:r>
             <a:endParaRPr lang="en-US" sz="1300" dirty="0"/>
           </a:p>
@@ -8099,33 +8420,69 @@
       </p:sp>
       <p:sp>
         <p:nvSpPr>
-          <p:cNvPr id="10" name="Text 8"/>
-          <p:cNvSpPr txBox="1"/>
-          <p:nvPr/>
-        </p:nvSpPr>
-        <p:spPr>
-          <a:xfrm>
-            <a:off x="2057400" y="3529584"/>
-            <a:ext cx="3840480" cy="512064"/>
-          </a:xfrm>
-          <a:prstGeom prst="rect">
-            <a:avLst/>
-          </a:prstGeom>
-          <a:noFill/>
-          <a:ln/>
-        </p:spPr>
-        <p:txBody>
-          <a:bodyPr wrap="square" lIns="0" tIns="0" rIns="0" bIns="0" rtlCol="0" anchor="ctr"/>
-          <a:lstStyle/>
-          <a:p>
-            <a:pPr indent="0" marL="0">
-              <a:lnSpc>
-                <a:spcPts val="1800"/>
-              </a:lnSpc>
-              <a:buNone/>
-            </a:pPr>
-            <a:r>
-              <a:rPr lang="en-US" sz="1300" dirty="0">
+          <p:cNvPr id="19" name="Text 17"/>
+          <p:cNvSpPr txBox="1"/>
+          <p:nvPr/>
+        </p:nvSpPr>
+        <p:spPr>
+          <a:xfrm>
+            <a:off x="685800" y="5084064"/>
+            <a:ext cx="3566160" cy="274320"/>
+          </a:xfrm>
+          <a:prstGeom prst="rect">
+            <a:avLst/>
+          </a:prstGeom>
+          <a:noFill/>
+          <a:ln/>
+        </p:spPr>
+        <p:txBody>
+          <a:bodyPr wrap="square" lIns="0" tIns="0" rIns="0" bIns="0" rtlCol="0" anchor="ctr"/>
+          <a:lstStyle/>
+          <a:p>
+            <a:pPr indent="0" marL="0">
+              <a:buNone/>
+            </a:pPr>
+            <a:r>
+              <a:rPr lang="en-US" sz="1600" b="1" dirty="0">
+                <a:solidFill>
+                  <a:srgbClr val="1E2761"/>
+                </a:solidFill>
+                <a:latin typeface="Cambria" pitchFamily="34" charset="0"/>
+                <a:ea typeface="Cambria" pitchFamily="34" charset="-122"/>
+                <a:cs typeface="Cambria" pitchFamily="34" charset="-120"/>
+              </a:rPr>
+              <a:t>Boulder, Colorado</a:t>
+            </a:r>
+            <a:endParaRPr lang="en-US" sz="1600" dirty="0"/>
+          </a:p>
+        </p:txBody>
+      </p:sp>
+      <p:sp>
+        <p:nvSpPr>
+          <p:cNvPr id="20" name="Text 18"/>
+          <p:cNvSpPr txBox="1"/>
+          <p:nvPr/>
+        </p:nvSpPr>
+        <p:spPr>
+          <a:xfrm>
+            <a:off x="685800" y="5394960"/>
+            <a:ext cx="3566160" cy="274320"/>
+          </a:xfrm>
+          <a:prstGeom prst="rect">
+            <a:avLst/>
+          </a:prstGeom>
+          <a:noFill/>
+          <a:ln/>
+        </p:spPr>
+        <p:txBody>
+          <a:bodyPr wrap="square" lIns="0" tIns="0" rIns="0" bIns="0" rtlCol="0" anchor="ctr"/>
+          <a:lstStyle/>
+          <a:p>
+            <a:pPr indent="0" marL="0">
+              <a:buNone/>
+            </a:pPr>
+            <a:r>
+              <a:rPr lang="en-US" sz="1250" dirty="0">
                 <a:solidFill>
                   <a:srgbClr val="5B6883"/>
                 </a:solidFill>
@@ -8133,80 +8490,155 @@
                 <a:ea typeface="Calibri" pitchFamily="34" charset="-122"/>
                 <a:cs typeface="Calibri" pitchFamily="34" charset="-120"/>
               </a:rPr>
-              <a:t>One technical owner on the city side. No procurement cycle to start.</a:t>
-            </a:r>
-            <a:endParaRPr lang="en-US" sz="1300" dirty="0"/>
-          </a:p>
-        </p:txBody>
-      </p:sp>
-      <p:sp>
-        <p:nvSpPr>
-          <p:cNvPr id="11" name="Text 9"/>
-          <p:cNvSpPr txBox="1"/>
-          <p:nvPr/>
-        </p:nvSpPr>
-        <p:spPr>
-          <a:xfrm>
-            <a:off x="1069848" y="4169664"/>
-            <a:ext cx="914400" cy="274320"/>
-          </a:xfrm>
-          <a:prstGeom prst="rect">
-            <a:avLst/>
-          </a:prstGeom>
-          <a:noFill/>
-          <a:ln/>
-        </p:spPr>
-        <p:txBody>
-          <a:bodyPr wrap="square" lIns="0" tIns="0" rIns="0" bIns="0" rtlCol="0" anchor="ctr"/>
-          <a:lstStyle/>
-          <a:p>
-            <a:pPr indent="0" marL="0">
-              <a:buNone/>
-            </a:pPr>
-            <a:r>
-              <a:rPr lang="en-US" sz="1300" b="1" dirty="0">
+              <a:t>Built here</a:t>
+            </a:r>
+            <a:endParaRPr lang="en-US" sz="1250" dirty="0"/>
+          </a:p>
+        </p:txBody>
+      </p:sp>
+      <p:sp>
+        <p:nvSpPr>
+          <p:cNvPr id="21" name="Text 19"/>
+          <p:cNvSpPr txBox="1"/>
+          <p:nvPr/>
+        </p:nvSpPr>
+        <p:spPr>
+          <a:xfrm>
+            <a:off x="4526280" y="5084064"/>
+            <a:ext cx="3566160" cy="274320"/>
+          </a:xfrm>
+          <a:prstGeom prst="rect">
+            <a:avLst/>
+          </a:prstGeom>
+          <a:noFill/>
+          <a:ln/>
+        </p:spPr>
+        <p:txBody>
+          <a:bodyPr wrap="square" lIns="0" tIns="0" rIns="0" bIns="0" rtlCol="0" anchor="ctr"/>
+          <a:lstStyle/>
+          <a:p>
+            <a:pPr indent="0" marL="0">
+              <a:buNone/>
+            </a:pPr>
+            <a:r>
+              <a:rPr lang="en-US" sz="1600" b="1" dirty="0">
                 <a:solidFill>
                   <a:srgbClr val="1E2761"/>
+                </a:solidFill>
+                <a:latin typeface="Cambria" pitchFamily="34" charset="0"/>
+                <a:ea typeface="Cambria" pitchFamily="34" charset="-122"/>
+                <a:cs typeface="Cambria" pitchFamily="34" charset="-120"/>
+              </a:rPr>
+              <a:t>Bootstrapped pre-seed</a:t>
+            </a:r>
+            <a:endParaRPr lang="en-US" sz="1600" dirty="0"/>
+          </a:p>
+        </p:txBody>
+      </p:sp>
+      <p:sp>
+        <p:nvSpPr>
+          <p:cNvPr id="22" name="Text 20"/>
+          <p:cNvSpPr txBox="1"/>
+          <p:nvPr/>
+        </p:nvSpPr>
+        <p:spPr>
+          <a:xfrm>
+            <a:off x="4526280" y="5394960"/>
+            <a:ext cx="3566160" cy="274320"/>
+          </a:xfrm>
+          <a:prstGeom prst="rect">
+            <a:avLst/>
+          </a:prstGeom>
+          <a:noFill/>
+          <a:ln/>
+        </p:spPr>
+        <p:txBody>
+          <a:bodyPr wrap="square" lIns="0" tIns="0" rIns="0" bIns="0" rtlCol="0" anchor="ctr"/>
+          <a:lstStyle/>
+          <a:p>
+            <a:pPr indent="0" marL="0">
+              <a:buNone/>
+            </a:pPr>
+            <a:r>
+              <a:rPr lang="en-US" sz="1250" dirty="0">
+                <a:solidFill>
+                  <a:srgbClr val="5B6883"/>
                 </a:solidFill>
                 <a:latin typeface="Calibri" pitchFamily="34" charset="0"/>
                 <a:ea typeface="Calibri" pitchFamily="34" charset="-122"/>
                 <a:cs typeface="Calibri" pitchFamily="34" charset="-120"/>
               </a:rPr>
-              <a:t>Result</a:t>
-            </a:r>
-            <a:endParaRPr lang="en-US" sz="1300" dirty="0"/>
-          </a:p>
-        </p:txBody>
-      </p:sp>
-      <p:sp>
-        <p:nvSpPr>
-          <p:cNvPr id="12" name="Text 10"/>
-          <p:cNvSpPr txBox="1"/>
-          <p:nvPr/>
-        </p:nvSpPr>
-        <p:spPr>
-          <a:xfrm>
-            <a:off x="2057400" y="4169664"/>
-            <a:ext cx="3840480" cy="512064"/>
-          </a:xfrm>
-          <a:prstGeom prst="rect">
-            <a:avLst/>
-          </a:prstGeom>
-          <a:noFill/>
-          <a:ln/>
-        </p:spPr>
-        <p:txBody>
-          <a:bodyPr wrap="square" lIns="0" tIns="0" rIns="0" bIns="0" rtlCol="0" anchor="ctr"/>
-          <a:lstStyle/>
-          <a:p>
-            <a:pPr indent="0" marL="0">
-              <a:lnSpc>
-                <a:spcPts val="1800"/>
-              </a:lnSpc>
-              <a:buNone/>
-            </a:pPr>
-            <a:r>
-              <a:rPr lang="en-US" sz="1300" dirty="0">
+              <a:t>No outside capital</a:t>
+            </a:r>
+            <a:endParaRPr lang="en-US" sz="1250" dirty="0"/>
+          </a:p>
+        </p:txBody>
+      </p:sp>
+      <p:sp>
+        <p:nvSpPr>
+          <p:cNvPr id="23" name="Text 21"/>
+          <p:cNvSpPr txBox="1"/>
+          <p:nvPr/>
+        </p:nvSpPr>
+        <p:spPr>
+          <a:xfrm>
+            <a:off x="8366760" y="5084064"/>
+            <a:ext cx="3566160" cy="274320"/>
+          </a:xfrm>
+          <a:prstGeom prst="rect">
+            <a:avLst/>
+          </a:prstGeom>
+          <a:noFill/>
+          <a:ln/>
+        </p:spPr>
+        <p:txBody>
+          <a:bodyPr wrap="square" lIns="0" tIns="0" rIns="0" bIns="0" rtlCol="0" anchor="ctr"/>
+          <a:lstStyle/>
+          <a:p>
+            <a:pPr indent="0" marL="0">
+              <a:buNone/>
+            </a:pPr>
+            <a:r>
+              <a:rPr lang="en-US" sz="1600" b="1" dirty="0">
+                <a:solidFill>
+                  <a:srgbClr val="1E2761"/>
+                </a:solidFill>
+                <a:latin typeface="Cambria" pitchFamily="34" charset="0"/>
+                <a:ea typeface="Cambria" pitchFamily="34" charset="-122"/>
+                <a:cs typeface="Cambria" pitchFamily="34" charset="-120"/>
+              </a:rPr>
+              <a:t>Working software</a:t>
+            </a:r>
+            <a:endParaRPr lang="en-US" sz="1600" dirty="0"/>
+          </a:p>
+        </p:txBody>
+      </p:sp>
+      <p:sp>
+        <p:nvSpPr>
+          <p:cNvPr id="24" name="Text 22"/>
+          <p:cNvSpPr txBox="1"/>
+          <p:nvPr/>
+        </p:nvSpPr>
+        <p:spPr>
+          <a:xfrm>
+            <a:off x="8366760" y="5394960"/>
+            <a:ext cx="3566160" cy="274320"/>
+          </a:xfrm>
+          <a:prstGeom prst="rect">
+            <a:avLst/>
+          </a:prstGeom>
+          <a:noFill/>
+          <a:ln/>
+        </p:spPr>
+        <p:txBody>
+          <a:bodyPr wrap="square" lIns="0" tIns="0" rIns="0" bIns="0" rtlCol="0" anchor="ctr"/>
+          <a:lstStyle/>
+          <a:p>
+            <a:pPr indent="0" marL="0">
+              <a:buNone/>
+            </a:pPr>
+            <a:r>
+              <a:rPr lang="en-US" sz="1250" dirty="0">
                 <a:solidFill>
                   <a:srgbClr val="5B6883"/>
                 </a:solidFill>
@@ -8214,455 +8646,45 @@
                 <a:ea typeface="Calibri" pitchFamily="34" charset="-122"/>
                 <a:cs typeface="Calibri" pitchFamily="34" charset="-120"/>
               </a:rPr>
-              <a:t>Agent identity, enforced policy, and evidence a third party can verify.</a:t>
-            </a:r>
-            <a:endParaRPr lang="en-US" sz="1300" dirty="0"/>
-          </a:p>
-        </p:txBody>
-      </p:sp>
-      <p:sp>
-        <p:nvSpPr>
-          <p:cNvPr id="13" name="Shape 11"/>
-          <p:cNvSpPr/>
-          <p:nvPr/>
-        </p:nvSpPr>
-        <p:spPr>
-          <a:xfrm>
-            <a:off x="6647688" y="1700784"/>
-            <a:ext cx="4855464" cy="3127248"/>
-          </a:xfrm>
-          <a:prstGeom prst="roundRect">
-            <a:avLst>
-              <a:gd name="adj" fmla="val 1462"/>
-            </a:avLst>
-          </a:prstGeom>
-          <a:solidFill>
-            <a:srgbClr val="FFF4E0"/>
-          </a:solidFill>
-          <a:ln w="19050">
-            <a:solidFill>
-              <a:srgbClr val="E3B45E"/>
-            </a:solidFill>
-            <a:prstDash val="solid"/>
-          </a:ln>
-        </p:spPr>
-      </p:sp>
-      <p:sp>
-        <p:nvSpPr>
-          <p:cNvPr id="14" name="Text 12"/>
-          <p:cNvSpPr txBox="1"/>
-          <p:nvPr/>
-        </p:nvSpPr>
-        <p:spPr>
-          <a:xfrm>
-            <a:off x="7031736" y="1975104"/>
-            <a:ext cx="4114800" cy="256032"/>
-          </a:xfrm>
-          <a:prstGeom prst="rect">
-            <a:avLst/>
-          </a:prstGeom>
-          <a:noFill/>
-          <a:ln/>
-        </p:spPr>
-        <p:txBody>
-          <a:bodyPr wrap="square" lIns="0" tIns="0" rIns="0" bIns="0" rtlCol="0" anchor="ctr"/>
-          <a:lstStyle/>
-          <a:p>
-            <a:pPr indent="0" marL="0">
-              <a:buNone/>
-            </a:pPr>
-            <a:r>
-              <a:rPr lang="en-US" sz="1000" b="1" spc="120" kern="0" dirty="0">
-                <a:solidFill>
-                  <a:srgbClr val="8A5A12"/>
-                </a:solidFill>
-                <a:latin typeface="Courier New" pitchFamily="34" charset="0"/>
-                <a:ea typeface="Courier New" pitchFamily="34" charset="-122"/>
-                <a:cs typeface="Courier New" pitchFamily="34" charset="-120"/>
-              </a:rPr>
-              <a:t>COLORADO ANCHOR</a:t>
-            </a:r>
-            <a:endParaRPr lang="en-US" sz="1000" dirty="0"/>
-          </a:p>
-        </p:txBody>
-      </p:sp>
-      <p:sp>
-        <p:nvSpPr>
-          <p:cNvPr id="15" name="Text 13"/>
-          <p:cNvSpPr txBox="1"/>
-          <p:nvPr/>
-        </p:nvSpPr>
-        <p:spPr>
-          <a:xfrm>
-            <a:off x="7031736" y="2304288"/>
-            <a:ext cx="4114800" cy="365760"/>
-          </a:xfrm>
-          <a:prstGeom prst="rect">
-            <a:avLst/>
-          </a:prstGeom>
-          <a:noFill/>
-          <a:ln/>
-        </p:spPr>
-        <p:txBody>
-          <a:bodyPr wrap="square" lIns="0" tIns="0" rIns="0" bIns="0" rtlCol="0" anchor="ctr"/>
-          <a:lstStyle/>
-          <a:p>
-            <a:pPr indent="0" marL="0">
-              <a:buNone/>
-            </a:pPr>
-            <a:r>
-              <a:rPr lang="en-US" sz="1700" b="1" dirty="0">
-                <a:solidFill>
-                  <a:srgbClr val="8A5A12"/>
-                </a:solidFill>
-                <a:latin typeface="Cambria" pitchFamily="34" charset="0"/>
-                <a:ea typeface="Cambria" pitchFamily="34" charset="-122"/>
-                <a:cs typeface="Cambria" pitchFamily="34" charset="-120"/>
-              </a:rPr>
-              <a:t>[ REPLACE THIS CARD ]</a:t>
-            </a:r>
-            <a:endParaRPr lang="en-US" sz="1700" dirty="0"/>
-          </a:p>
-        </p:txBody>
-      </p:sp>
-      <p:sp>
-        <p:nvSpPr>
-          <p:cNvPr id="16" name="Text 14"/>
-          <p:cNvSpPr txBox="1"/>
-          <p:nvPr/>
-        </p:nvSpPr>
-        <p:spPr>
-          <a:xfrm>
-            <a:off x="7031736" y="2779776"/>
-            <a:ext cx="4114800" cy="1828800"/>
-          </a:xfrm>
-          <a:prstGeom prst="rect">
-            <a:avLst/>
-          </a:prstGeom>
-          <a:noFill/>
-          <a:ln/>
-        </p:spPr>
-        <p:txBody>
-          <a:bodyPr wrap="square" lIns="0" tIns="0" rIns="0" bIns="0" rtlCol="0" anchor="ctr"/>
-          <a:lstStyle/>
-          <a:p>
-            <a:pPr indent="0" marL="0">
-              <a:lnSpc>
-                <a:spcPts val="1800"/>
-              </a:lnSpc>
-              <a:buNone/>
-            </a:pPr>
-            <a:r>
-              <a:rPr lang="en-US" sz="1250" dirty="0">
-                <a:solidFill>
-                  <a:srgbClr val="8A5A12"/>
+              <a:t>Not a prototype</a:t>
+            </a:r>
+            <a:endParaRPr lang="en-US" sz="1250" dirty="0"/>
+          </a:p>
+        </p:txBody>
+      </p:sp>
+      <p:sp>
+        <p:nvSpPr>
+          <p:cNvPr id="25" name="Text 23"/>
+          <p:cNvSpPr txBox="1"/>
+          <p:nvPr/>
+        </p:nvSpPr>
+        <p:spPr>
+          <a:xfrm>
+            <a:off x="685800" y="6327648"/>
+            <a:ext cx="2743200" cy="237744"/>
+          </a:xfrm>
+          <a:prstGeom prst="rect">
+            <a:avLst/>
+          </a:prstGeom>
+          <a:noFill/>
+          <a:ln/>
+        </p:spPr>
+        <p:txBody>
+          <a:bodyPr wrap="square" lIns="0" tIns="0" rIns="0" bIns="0" rtlCol="0" anchor="ctr"/>
+          <a:lstStyle/>
+          <a:p>
+            <a:pPr indent="0" marL="0">
+              <a:buNone/>
+            </a:pPr>
+            <a:r>
+              <a:rPr lang="en-US" sz="950" dirty="0">
+                <a:solidFill>
+                  <a:srgbClr val="5B6883"/>
                 </a:solidFill>
                 <a:latin typeface="Calibri" pitchFamily="34" charset="0"/>
                 <a:ea typeface="Calibri" pitchFamily="34" charset="-122"/>
                 <a:cs typeface="Calibri" pitchFamily="34" charset="-120"/>
               </a:rPr>
-              <a:t>Name the Colorado agency, department, or district you have already spoken with, the person who owns the workflow, and the workflow itself.</a:t>
-            </a:r>
-            <a:endParaRPr lang="en-US" sz="1250" dirty="0"/>
-          </a:p>
-          <a:p>
-            <a:pPr indent="0" marL="0">
-              <a:lnSpc>
-                <a:spcPts val="1800"/>
-              </a:lnSpc>
-              <a:buNone/>
-            </a:pPr>
-            <a:endParaRPr lang="en-US" sz="1250" dirty="0"/>
-          </a:p>
-          <a:p>
-            <a:pPr indent="0" marL="0">
-              <a:lnSpc>
-                <a:spcPts val="1800"/>
-              </a:lnSpc>
-              <a:buNone/>
-            </a:pPr>
-            <a:r>
-              <a:rPr lang="en-US" sz="1250" dirty="0">
-                <a:solidFill>
-                  <a:srgbClr val="8A5A12"/>
-                </a:solidFill>
-                <a:latin typeface="Calibri" pitchFamily="34" charset="0"/>
-                <a:ea typeface="Calibri" pitchFamily="34" charset="-122"/>
-                <a:cs typeface="Calibri" pitchFamily="34" charset="-120"/>
-              </a:rPr>
-              <a:t>If no conversation exists yet, name the specific Denver workflow you have scoped and say what you need to start it. Judges select for local traction — a named workflow beats a generic one.</a:t>
-            </a:r>
-            <a:endParaRPr lang="en-US" sz="1250" dirty="0"/>
-          </a:p>
-        </p:txBody>
-      </p:sp>
-      <p:sp>
-        <p:nvSpPr>
-          <p:cNvPr id="17" name="Text 15"/>
-          <p:cNvSpPr txBox="1"/>
-          <p:nvPr/>
-        </p:nvSpPr>
-        <p:spPr>
-          <a:xfrm>
-            <a:off x="685800" y="5084064"/>
-            <a:ext cx="3566160" cy="274320"/>
-          </a:xfrm>
-          <a:prstGeom prst="rect">
-            <a:avLst/>
-          </a:prstGeom>
-          <a:noFill/>
-          <a:ln/>
-        </p:spPr>
-        <p:txBody>
-          <a:bodyPr wrap="square" lIns="0" tIns="0" rIns="0" bIns="0" rtlCol="0" anchor="ctr"/>
-          <a:lstStyle/>
-          <a:p>
-            <a:pPr indent="0" marL="0">
-              <a:buNone/>
-            </a:pPr>
-            <a:r>
-              <a:rPr lang="en-US" sz="1600" b="1" dirty="0">
-                <a:solidFill>
-                  <a:srgbClr val="1E2761"/>
-                </a:solidFill>
-                <a:latin typeface="Cambria" pitchFamily="34" charset="0"/>
-                <a:ea typeface="Cambria" pitchFamily="34" charset="-122"/>
-                <a:cs typeface="Cambria" pitchFamily="34" charset="-120"/>
-              </a:rPr>
-              <a:t>Boulder, Colorado</a:t>
-            </a:r>
-            <a:endParaRPr lang="en-US" sz="1600" dirty="0"/>
-          </a:p>
-        </p:txBody>
-      </p:sp>
-      <p:sp>
-        <p:nvSpPr>
-          <p:cNvPr id="18" name="Text 16"/>
-          <p:cNvSpPr txBox="1"/>
-          <p:nvPr/>
-        </p:nvSpPr>
-        <p:spPr>
-          <a:xfrm>
-            <a:off x="685800" y="5394960"/>
-            <a:ext cx="3566160" cy="274320"/>
-          </a:xfrm>
-          <a:prstGeom prst="rect">
-            <a:avLst/>
-          </a:prstGeom>
-          <a:noFill/>
-          <a:ln/>
-        </p:spPr>
-        <p:txBody>
-          <a:bodyPr wrap="square" lIns="0" tIns="0" rIns="0" bIns="0" rtlCol="0" anchor="ctr"/>
-          <a:lstStyle/>
-          <a:p>
-            <a:pPr indent="0" marL="0">
-              <a:buNone/>
-            </a:pPr>
-            <a:r>
-              <a:rPr lang="en-US" sz="1250" dirty="0">
-                <a:solidFill>
-                  <a:srgbClr val="5B6883"/>
-                </a:solidFill>
-                <a:latin typeface="Calibri" pitchFamily="34" charset="0"/>
-                <a:ea typeface="Calibri" pitchFamily="34" charset="-122"/>
-                <a:cs typeface="Calibri" pitchFamily="34" charset="-120"/>
-              </a:rPr>
-              <a:t>Built here</a:t>
-            </a:r>
-            <a:endParaRPr lang="en-US" sz="1250" dirty="0"/>
-          </a:p>
-        </p:txBody>
-      </p:sp>
-      <p:sp>
-        <p:nvSpPr>
-          <p:cNvPr id="19" name="Text 17"/>
-          <p:cNvSpPr txBox="1"/>
-          <p:nvPr/>
-        </p:nvSpPr>
-        <p:spPr>
-          <a:xfrm>
-            <a:off x="4526280" y="5084064"/>
-            <a:ext cx="3566160" cy="274320"/>
-          </a:xfrm>
-          <a:prstGeom prst="rect">
-            <a:avLst/>
-          </a:prstGeom>
-          <a:noFill/>
-          <a:ln/>
-        </p:spPr>
-        <p:txBody>
-          <a:bodyPr wrap="square" lIns="0" tIns="0" rIns="0" bIns="0" rtlCol="0" anchor="ctr"/>
-          <a:lstStyle/>
-          <a:p>
-            <a:pPr indent="0" marL="0">
-              <a:buNone/>
-            </a:pPr>
-            <a:r>
-              <a:rPr lang="en-US" sz="1600" b="1" dirty="0">
-                <a:solidFill>
-                  <a:srgbClr val="1E2761"/>
-                </a:solidFill>
-                <a:latin typeface="Cambria" pitchFamily="34" charset="0"/>
-                <a:ea typeface="Cambria" pitchFamily="34" charset="-122"/>
-                <a:cs typeface="Cambria" pitchFamily="34" charset="-120"/>
-              </a:rPr>
-              <a:t>Bootstrapped pre-seed</a:t>
-            </a:r>
-            <a:endParaRPr lang="en-US" sz="1600" dirty="0"/>
-          </a:p>
-        </p:txBody>
-      </p:sp>
-      <p:sp>
-        <p:nvSpPr>
-          <p:cNvPr id="20" name="Text 18"/>
-          <p:cNvSpPr txBox="1"/>
-          <p:nvPr/>
-        </p:nvSpPr>
-        <p:spPr>
-          <a:xfrm>
-            <a:off x="4526280" y="5394960"/>
-            <a:ext cx="3566160" cy="274320"/>
-          </a:xfrm>
-          <a:prstGeom prst="rect">
-            <a:avLst/>
-          </a:prstGeom>
-          <a:noFill/>
-          <a:ln/>
-        </p:spPr>
-        <p:txBody>
-          <a:bodyPr wrap="square" lIns="0" tIns="0" rIns="0" bIns="0" rtlCol="0" anchor="ctr"/>
-          <a:lstStyle/>
-          <a:p>
-            <a:pPr indent="0" marL="0">
-              <a:buNone/>
-            </a:pPr>
-            <a:r>
-              <a:rPr lang="en-US" sz="1250" dirty="0">
-                <a:solidFill>
-                  <a:srgbClr val="5B6883"/>
-                </a:solidFill>
-                <a:latin typeface="Calibri" pitchFamily="34" charset="0"/>
-                <a:ea typeface="Calibri" pitchFamily="34" charset="-122"/>
-                <a:cs typeface="Calibri" pitchFamily="34" charset="-120"/>
-              </a:rPr>
-              <a:t>No outside capital</a:t>
-            </a:r>
-            <a:endParaRPr lang="en-US" sz="1250" dirty="0"/>
-          </a:p>
-        </p:txBody>
-      </p:sp>
-      <p:sp>
-        <p:nvSpPr>
-          <p:cNvPr id="21" name="Text 19"/>
-          <p:cNvSpPr txBox="1"/>
-          <p:nvPr/>
-        </p:nvSpPr>
-        <p:spPr>
-          <a:xfrm>
-            <a:off x="8366760" y="5084064"/>
-            <a:ext cx="3566160" cy="274320"/>
-          </a:xfrm>
-          <a:prstGeom prst="rect">
-            <a:avLst/>
-          </a:prstGeom>
-          <a:noFill/>
-          <a:ln/>
-        </p:spPr>
-        <p:txBody>
-          <a:bodyPr wrap="square" lIns="0" tIns="0" rIns="0" bIns="0" rtlCol="0" anchor="ctr"/>
-          <a:lstStyle/>
-          <a:p>
-            <a:pPr indent="0" marL="0">
-              <a:buNone/>
-            </a:pPr>
-            <a:r>
-              <a:rPr lang="en-US" sz="1600" b="1" dirty="0">
-                <a:solidFill>
-                  <a:srgbClr val="1E2761"/>
-                </a:solidFill>
-                <a:latin typeface="Cambria" pitchFamily="34" charset="0"/>
-                <a:ea typeface="Cambria" pitchFamily="34" charset="-122"/>
-                <a:cs typeface="Cambria" pitchFamily="34" charset="-120"/>
-              </a:rPr>
-              <a:t>Working software</a:t>
-            </a:r>
-            <a:endParaRPr lang="en-US" sz="1600" dirty="0"/>
-          </a:p>
-        </p:txBody>
-      </p:sp>
-      <p:sp>
-        <p:nvSpPr>
-          <p:cNvPr id="22" name="Text 20"/>
-          <p:cNvSpPr txBox="1"/>
-          <p:nvPr/>
-        </p:nvSpPr>
-        <p:spPr>
-          <a:xfrm>
-            <a:off x="8366760" y="5394960"/>
-            <a:ext cx="3566160" cy="274320"/>
-          </a:xfrm>
-          <a:prstGeom prst="rect">
-            <a:avLst/>
-          </a:prstGeom>
-          <a:noFill/>
-          <a:ln/>
-        </p:spPr>
-        <p:txBody>
-          <a:bodyPr wrap="square" lIns="0" tIns="0" rIns="0" bIns="0" rtlCol="0" anchor="ctr"/>
-          <a:lstStyle/>
-          <a:p>
-            <a:pPr indent="0" marL="0">
-              <a:buNone/>
-            </a:pPr>
-            <a:r>
-              <a:rPr lang="en-US" sz="1250" dirty="0">
-                <a:solidFill>
-                  <a:srgbClr val="5B6883"/>
-                </a:solidFill>
-                <a:latin typeface="Calibri" pitchFamily="34" charset="0"/>
-                <a:ea typeface="Calibri" pitchFamily="34" charset="-122"/>
-                <a:cs typeface="Calibri" pitchFamily="34" charset="-120"/>
-              </a:rPr>
-              <a:t>Not a prototype</a:t>
-            </a:r>
-            <a:endParaRPr lang="en-US" sz="1250" dirty="0"/>
-          </a:p>
-        </p:txBody>
-      </p:sp>
-      <p:sp>
-        <p:nvSpPr>
-          <p:cNvPr id="23" name="Text 21"/>
-          <p:cNvSpPr txBox="1"/>
-          <p:nvPr/>
-        </p:nvSpPr>
-        <p:spPr>
-          <a:xfrm>
-            <a:off x="685800" y="6327648"/>
-            <a:ext cx="2743200" cy="237744"/>
-          </a:xfrm>
-          <a:prstGeom prst="rect">
-            <a:avLst/>
-          </a:prstGeom>
-          <a:noFill/>
-          <a:ln/>
-        </p:spPr>
-        <p:txBody>
-          <a:bodyPr wrap="square" lIns="0" tIns="0" rIns="0" bIns="0" rtlCol="0" anchor="ctr"/>
-          <a:lstStyle/>
-          <a:p>
-            <a:pPr indent="0" marL="0">
-              <a:buNone/>
-            </a:pPr>
-            <a:r>
-              <a:rPr lang="en-US" sz="950" dirty="0">
-                <a:solidFill>
-                  <a:srgbClr val="5B6883"/>
-                </a:solidFill>
-                <a:latin typeface="Calibri" pitchFamily="34" charset="0"/>
-                <a:ea typeface="Calibri" pitchFamily="34" charset="-122"/>
-                <a:cs typeface="Calibri" pitchFamily="34" charset="-120"/>
-              </a:rPr>
               <a:t>AI Identity</a:t>
             </a:r>
             <a:endParaRPr lang="en-US" sz="950" dirty="0"/>
@@ -8671,7 +8693,7 @@
       </p:sp>
       <p:sp>
         <p:nvSpPr>
-          <p:cNvPr id="24" name="Text 22"/>
+          <p:cNvPr id="26" name="Text 24"/>
           <p:cNvSpPr txBox="1"/>
           <p:nvPr/>
         </p:nvSpPr>

</xml_diff>